<commit_message>
Deck v2: corrections from the persona session (rush base, END and IMPROVE steps, nahi chahiye, handler or pool, evidence counts)
Co-Authored-By: Claude Sonnet 5.5 <noreply@anthropic.com>
Claude-Session: https://claude.ai/code/session_011uVttPTSPum9783y8wvy9a
</commit_message>
<xml_diff>
--- a/outputs/plans/VANI_Persona_Design_Deck_v2_visual.pptx
+++ b/outputs/plans/VANI_Persona_Design_Deck_v2_visual.pptx
@@ -986,7 +986,7 @@
           <a:lstStyle/>
           <a:p>
             <a:r>
-              <a:t>Left: today's VANI uses one script, one voice and one pace for every seller. The opening rests on an enquiry count and the city; the seller details we hold (similar sellers, live buy-lead data, order value, catalogue quality, plan, handler) are not in the call. Right: a persona designed per seller, adapted live. Number: a rush signal in the seller's words (busy, jaldi, time nahi, baad mein, driving, call back) appears in about 21% of transcribed calls; those calls end with a meeting about 14% of the time against about 26% when no rush signal appears (keyword method on 11,834 transcribed calls, approximate). A rushed seller halves the chance of a meeting, and today's VANI does not change for them.</a:t>
+              <a:t>Left: today's VANI uses one script, one voice and one pace for every seller. The opening rests on an enquiry count and the city; the seller details we hold (similar sellers, live buy-lead data, order value, catalogue quality, plan, handler) are not in the call. Right: a persona designed per seller, adapted live. Number: a rush signal in the seller's words (busy, jaldi, time nahi, baad mein, driving, call back) appears in about 21% of transcribed calls; those calls end with a meeting about 14% of the time against about 26% when no rush signal appears (keyword method on 11,834 transcribed calls, approximate; the base in that set is 23.4%). Transcribed calls skew toward engaged sellers (22.4% meeting rate against 11.5% over all 269,455 answered calls), so read the rush effect inside that set, not against the 11.5% base. A rushed seller roughly halves the chance of a meeting, and today's VANI does not change for them.</a:t>
             </a:r>
           </a:p>
         </p:txBody>
@@ -1218,7 +1218,7 @@
           <a:lstStyle/>
           <a:p>
             <a:r>
-              <a:t>START of call: the Sarvam voice agent's start tool applies the persona before the first word: voice, pace, pitch, the start language and the opening line; the persona and hook fill one fixed prompt through per-call variables. MID-CALL: a signal tool runs on every seller turn and returns the seller's mode and a directive that overrides the speaking style for that reply only (rushed: one short sentence and a callback; confused: one idea in short phrases; frustrated: brief apology, no pitch; interested: answer briefly and ask for the day and time; declined: keep the call open; bot question: sidestep once, then 'virtual assistant'; opt-out: apologise and end; language switch: reply in the seller's language). Voice, pace and pitch are fixed after the start (platform limit); tone changes through the words. Every change is written to a switch log: turn, utterance, from mode, to mode, cue, change, reason. END: the booking tool records the meeting with the seller's sales handler, or a callback; VANI never quotes a plan or price. IMPROVE: Claude reviews the call against compliance rules (7 fatal and 13 non-fatal items); results update persona and hook scoreboards by seller segment and per-field value groups; reports show meeting rate by reason type and uplift against the control. Scoreboards are empty at the start; picks are a division-based lean plus a random draw until real calls arrive.</a:t>
+              <a:t>START of call: the Sarvam voice agent's start tool applies the persona before the first word: voice, pace, pitch, the start language and the opening line; the persona and hook fill one fixed prompt through per-call variables. MID-CALL: a signal tool runs on every seller turn and returns the seller's mode and a directive that overrides the speaking style for that reply only (rushed: one short sentence and a callback; confused: one idea in short phrases; frustrated: brief apology, no pitch; interested: answer briefly and ask for the day and time; declined: keep the call open; bot question: sidestep once, then 'virtual assistant'; opt-out: apologise and end; language switch: reply in the seller's language). Voice, pace and pitch are fixed after the start (platform limit); tone changes through the words. Every change is written to a switch log: turn, utterance, from mode, to mode, cue, change, reason. END: the booking tool records the meeting with the seller's sales handler when a name exists (for a pool: 'our IndiaMART executive'), or a callback; after booking VANI asks 'anything else?' and ends only on the seller's no or goodbye; the call ends early only on an explicit request (stop calling, cut the call, do not call); 'not interested' keeps the line open (the hook again, then one topic per 'no'). VANI never quotes a plan or price. IMPROVE: Claude reviews the call against compliance rules (7 fatal and 13 non-fatal items) and the call-rule checks R1-R6 (pass, fail or unknown per language); results update persona and hook scoreboards by seller segment and per-field value groups; reports show meeting rate by reason type and uplift against the control. Scoreboards are empty at the start; picks are a division-based lean plus a random draw until real calls arrive.</a:t>
             </a:r>
           </a:p>
         </p:txBody>
@@ -1276,7 +1276,7 @@
           <a:lstStyle/>
           <a:p>
             <a:r>
-              <a:t>Examples of the live signal tool at work. Every seller turn is read; the tool returns a mode (rushed, frustrated, confused, interested, declined, bot question, opt-out, language switch; question and handler questions as one-turn overlays) and a directive. In scripted test calls every switch type fired on the same turn, including a language switch from Marathi to Hindi to English. A switch log row records: turn, utterance, from mode, to mode, cue, directive id, change made, reason, whether asking for the meeting is allowed, milliseconds. Honest limits: voice, pace and pitch cannot change mid-call (a Sarvam platform limit), tone changes through wording; the keyword classifier is a baseline with about 0.60 measured accuracy on a small reviewed set, presented as a measurement not a production figure; a slower external classifier (Jev) was parked because of latency. Handler: VANI names the sales handler when one exists, and the meeting is booked with that person.</a:t>
+              <a:t>Examples of the live signal tool at work. Every seller turn is read; the tool returns a mode (rushed, frustrated, confused, interested, declined, bot question, opt-out, language switch; question and handler questions as one-turn overlays) and a directive. In scripted test calls every switch type fired on the same turn, including a language switch from Marathi to Hindi to English. A switch log row records: turn, utterance, from mode, to mode, cue, directive id, change made, reason, whether asking for the meeting is allowed, milliseconds. Honest limits: voice, pace and pitch cannot change mid-call (a Sarvam platform limit), tone changes through wording; the keyword classifier is a baseline with about 0.60 measured accuracy on a small reviewed set, presented as a measurement not a production figure; a slower external classifier (Jev) was parked because of latency. Handler: with a handler name VANI says the name and books with that person; with a pool it says 'our IndiaMART team handles your account; the executive will introduce themselves when they call' and never a made-up name. 'Nahi chahiye' keeps the call open and restates the hook.</a:t>
             </a:r>
           </a:p>
         </p:txBody>
@@ -1334,7 +1334,7 @@
           <a:lstStyle/>
           <a:p>
             <a:r>
-              <a:t>Context builder: offline PS07 and Global Context files, internal APIs (data warehouse, user service, company page) and read-only queries on the buy-lead and catalogue databases write one folder per seller (laptop, VPN). Safe export: names become tokens, a hard PII check refuses any leak, sources are stripped; real names stay on the laptop. Persona agent: Claude Opus 5.5 in an isolated Daytona sandbox; scripts compute traits, states, guards and hook eligibility and propose the top two personas; the agent selects one and decides every field with a checkable reason; a single writer tool, read log, stop gate and validator refuse anything uncited. Compile: the validated persona becomes the Sarvam agent's per-call variables and prompt sections; names are filled in only then, on the laptop. Voice call: the Sarvam voice agent (speech to text, language model, text to speech) with a start tool, a signal tool and a booking tool, one fixed prompt template with per-call variables, and the IndiaMART knowledge base. Review and learning: Claude reviews each call; scoreboards update by seller segment. Compliance: identity rule, verified facts only, no selling on the call, 7 fatal and 13 non-fatal rubric items checked before and after each call; humans approve persona library changes.</a:t>
+              <a:t>Context builder: offline PS07 and Global Context files, internal APIs (data warehouse, user service, company page) and read-only queries on the buy-lead and catalogue databases write one folder per seller (laptop, VPN). Safe export: names become tokens, a hard PII check refuses any leak, sources are stripped; real names stay on the laptop. Persona agent: Claude Opus 5.5 in an isolated Daytona sandbox; scripts compute traits, states, guards and hook eligibility and propose the top two personas; the agent selects one and decides every field with a checkable reason; a single writer tool, read log, stop gate and validator refuse anything uncited. Compile: the validated persona becomes the Sarvam agent's per-call variables and prompt sections; names are filled in only then, on the laptop. Voice call: the Sarvam voice agent (speech to text, language model, text to speech) with a start tool, a signal tool and a booking tool, one fixed prompt template with per-call variables, and the IndiaMART knowledge base. Review and learning: Claude reviews each call; scoreboards update by seller segment. Compliance: identity rule (never AI, bot or manager; never claims to be human; if pressed, 'IndiaMART's virtual assistant'), verified facts only, no selling on the call, 7 fatal and 13 non-fatal rubric items checked before and after each call; humans approve persona library changes.</a:t>
             </a:r>
           </a:p>
         </p:txBody>
@@ -1450,7 +1450,7 @@
           <a:lstStyle/>
           <a:p>
             <a:r>
-              <a:t>Planned scenarios; videos to be added. Call 1: a free seller in a regional-language region: warm local persona, profile-gap hook, language follows the seller. Call 2: a paying seller with buy-lead data: numbers-first persona, credit-usage or money-lead hook; the seller says 'busy', VANI shortens and offers a callback. Call 3: a high-turnover seller: senior persona, English start; the seller asks about the handler, VANI names the executive and books the meeting. Evidence to date: full persona runs on the sandbox for 3 sellers (about 2 minutes, about one dollar each; validation passed twice), about 6 real phone tests and 15 scripted voice calls where all 21 to 22 per-call variables arrived, 0 fatal review items on the reviewed call, agent response time about 0.8 to 1.6 seconds per turn, languages tested Marathi, Hindi, English and Telugu. Recordings contain real seller details and are shared only with approval.</a:t>
+              <a:t>Planned scenarios; videos to be added. Call 1: a free seller in a regional-language region: warm local persona, profile-gap hook, language follows the seller. Call 2: a paying seller with buy-lead data: numbers-first persona, credit-usage or money-lead hook; the seller says 'busy', VANI shortens and offers a callback. Call 3: a high-turnover seller: senior persona, English start; the seller asks about the handler, VANI names the executive and books the meeting. Evidence to date: 7 full persona runs on the sandbox (1 more running; about 2 to 3 minutes and $1 to $1.5 each; validation passed twice), about 7 real phone tests and about 16 scripted voice calls where all 21 to 22 per-call variables arrived, 0 fatal review items on the reviewed call, agent response time about 0.8 to 1.6 seconds per turn, languages tested Marathi, Hindi, English and Telugu. Recordings contain real seller details and are shared only with approval.</a:t>
             </a:r>
           </a:p>
         </p:txBody>
@@ -12247,7 +12247,7 @@
                 </a:solidFill>
                 <a:latin typeface="Arial"/>
               </a:rPr>
-              <a:t>14% vs 26%</a:t>
+              <a:t>26% to 14%</a:t>
             </a:r>
           </a:p>
         </p:txBody>
@@ -12286,7 +12286,7 @@
                 </a:solidFill>
                 <a:latin typeface="Arial"/>
               </a:rPr>
-              <a:t>meeting rate when the seller sounds rushed vs not (halves)</a:t>
+              <a:t>in transcribed calls (n = 11,834), a rush signal cuts the meeting rate</a:t>
             </a:r>
           </a:p>
         </p:txBody>
@@ -15553,7 +15553,24 @@
                 </a:solidFill>
                 <a:latin typeface="Arial"/>
               </a:rPr>
-              <a:t>With the sales handler</a:t>
+              <a:t>With the sales handler, or our executive</a:t>
+            </a:r>
+          </a:p>
+          <a:p>
+            <a:pPr algn="l" marL="182880" indent="-164592">
+              <a:spcAft>
+                <a:spcPts val="600"/>
+              </a:spcAft>
+              <a:buChar char="•"/>
+            </a:pPr>
+            <a:r>
+              <a:rPr sz="1300" b="0">
+                <a:solidFill>
+                  <a:srgbClr val="262626"/>
+                </a:solidFill>
+                <a:latin typeface="Arial"/>
+              </a:rPr>
+              <a:t>Then: anything else?</a:t>
             </a:r>
           </a:p>
           <a:p>
@@ -15748,7 +15765,7 @@
                 </a:solidFill>
                 <a:latin typeface="Arial"/>
               </a:rPr>
-              <a:t>Review the call</a:t>
+              <a:t>Review the call, rule checks R1-R6</a:t>
             </a:r>
           </a:p>
           <a:p>
@@ -15916,8 +15933,8 @@
         </p:nvSpPr>
         <p:spPr>
           <a:xfrm>
-            <a:off x="566928" y="1417320"/>
-            <a:ext cx="4754880" cy="731520"/>
+            <a:off x="566928" y="1371600"/>
+            <a:ext cx="4754880" cy="621792"/>
           </a:xfrm>
           <a:prstGeom prst="roundRect">
             <a:avLst>
@@ -15964,7 +15981,7 @@
                 </a:solidFill>
                 <a:latin typeface="Arial"/>
               </a:rPr>
-              <a:t>“I'm busy right now”</a:t>
+              <a:t>“Nahi chahiye”</a:t>
             </a:r>
           </a:p>
         </p:txBody>
@@ -15977,14 +15994,14 @@
         </p:nvSpPr>
         <p:spPr>
           <a:xfrm>
-            <a:off x="5440680" y="1600200"/>
+            <a:off x="5440680" y="1499616"/>
             <a:ext cx="457200" cy="365760"/>
           </a:xfrm>
           <a:prstGeom prst="rightArrow">
             <a:avLst/>
           </a:prstGeom>
           <a:solidFill>
-            <a:srgbClr val="002060"/>
+            <a:srgbClr val="E08A00"/>
           </a:solidFill>
           <a:ln>
             <a:noFill/>
@@ -16020,8 +16037,8 @@
         </p:nvSpPr>
         <p:spPr>
           <a:xfrm>
-            <a:off x="6035040" y="1417320"/>
-            <a:ext cx="5577840" cy="731520"/>
+            <a:off x="6035040" y="1371600"/>
+            <a:ext cx="5577840" cy="621792"/>
           </a:xfrm>
           <a:prstGeom prst="roundRect">
             <a:avLst>
@@ -16029,7 +16046,7 @@
             </a:avLst>
           </a:prstGeom>
           <a:solidFill>
-            <a:srgbClr val="002060"/>
+            <a:srgbClr val="E08A00"/>
           </a:solidFill>
           <a:ln>
             <a:noFill/>
@@ -16066,7 +16083,7 @@
                 </a:solidFill>
                 <a:latin typeface="Arial"/>
               </a:rPr>
-              <a:t>One short sentence, offers a callback</a:t>
+              <a:t>Stays on the line, restates the hook</a:t>
             </a:r>
           </a:p>
         </p:txBody>
@@ -16079,8 +16096,8 @@
         </p:nvSpPr>
         <p:spPr>
           <a:xfrm>
-            <a:off x="566928" y="2313432"/>
-            <a:ext cx="4754880" cy="731520"/>
+            <a:off x="566928" y="2130552"/>
+            <a:ext cx="4754880" cy="621792"/>
           </a:xfrm>
           <a:prstGeom prst="roundRect">
             <a:avLst>
@@ -16127,7 +16144,7 @@
                 </a:solidFill>
                 <a:latin typeface="Arial"/>
               </a:rPr>
-              <a:t>“Samajh nahi aaya”</a:t>
+              <a:t>“I'm busy right now”</a:t>
             </a:r>
           </a:p>
         </p:txBody>
@@ -16140,14 +16157,14 @@
         </p:nvSpPr>
         <p:spPr>
           <a:xfrm>
-            <a:off x="5440680" y="2496312"/>
+            <a:off x="5440680" y="2258568"/>
             <a:ext cx="457200" cy="365760"/>
           </a:xfrm>
           <a:prstGeom prst="rightArrow">
             <a:avLst/>
           </a:prstGeom>
           <a:solidFill>
-            <a:srgbClr val="2EA896"/>
+            <a:srgbClr val="002060"/>
           </a:solidFill>
           <a:ln>
             <a:noFill/>
@@ -16183,8 +16200,8 @@
         </p:nvSpPr>
         <p:spPr>
           <a:xfrm>
-            <a:off x="6035040" y="2313432"/>
-            <a:ext cx="5577840" cy="731520"/>
+            <a:off x="6035040" y="2130552"/>
+            <a:ext cx="5577840" cy="621792"/>
           </a:xfrm>
           <a:prstGeom prst="roundRect">
             <a:avLst>
@@ -16192,7 +16209,7 @@
             </a:avLst>
           </a:prstGeom>
           <a:solidFill>
-            <a:srgbClr val="2EA896"/>
+            <a:srgbClr val="002060"/>
           </a:solidFill>
           <a:ln>
             <a:noFill/>
@@ -16229,7 +16246,7 @@
                 </a:solidFill>
                 <a:latin typeface="Arial"/>
               </a:rPr>
-              <a:t>One idea, simple short phrases</a:t>
+              <a:t>One short sentence, offers a callback</a:t>
             </a:r>
           </a:p>
         </p:txBody>
@@ -16242,8 +16259,8 @@
         </p:nvSpPr>
         <p:spPr>
           <a:xfrm>
-            <a:off x="566928" y="3209544"/>
-            <a:ext cx="4754880" cy="731520"/>
+            <a:off x="566928" y="2889504"/>
+            <a:ext cx="4754880" cy="621792"/>
           </a:xfrm>
           <a:prstGeom prst="roundRect">
             <a:avLst>
@@ -16290,7 +16307,7 @@
                 </a:solidFill>
                 <a:latin typeface="Arial"/>
               </a:rPr>
-              <a:t>“Kitni baar call karoge!”</a:t>
+              <a:t>“Samajh nahi aaya”</a:t>
             </a:r>
           </a:p>
         </p:txBody>
@@ -16303,14 +16320,14 @@
         </p:nvSpPr>
         <p:spPr>
           <a:xfrm>
-            <a:off x="5440680" y="3392424"/>
+            <a:off x="5440680" y="3017520"/>
             <a:ext cx="457200" cy="365760"/>
           </a:xfrm>
           <a:prstGeom prst="rightArrow">
             <a:avLst/>
           </a:prstGeom>
           <a:solidFill>
-            <a:srgbClr val="C00000"/>
+            <a:srgbClr val="2EA896"/>
           </a:solidFill>
           <a:ln>
             <a:noFill/>
@@ -16346,8 +16363,8 @@
         </p:nvSpPr>
         <p:spPr>
           <a:xfrm>
-            <a:off x="6035040" y="3209544"/>
-            <a:ext cx="5577840" cy="731520"/>
+            <a:off x="6035040" y="2889504"/>
+            <a:ext cx="5577840" cy="621792"/>
           </a:xfrm>
           <a:prstGeom prst="roundRect">
             <a:avLst>
@@ -16355,7 +16372,7 @@
             </a:avLst>
           </a:prstGeom>
           <a:solidFill>
-            <a:srgbClr val="C00000"/>
+            <a:srgbClr val="2EA896"/>
           </a:solidFill>
           <a:ln>
             <a:noFill/>
@@ -16392,7 +16409,7 @@
                 </a:solidFill>
                 <a:latin typeface="Arial"/>
               </a:rPr>
-              <a:t>Brief apology, stops the pitch</a:t>
+              <a:t>One idea, simple short phrases</a:t>
             </a:r>
           </a:p>
         </p:txBody>
@@ -16405,8 +16422,8 @@
         </p:nvSpPr>
         <p:spPr>
           <a:xfrm>
-            <a:off x="566928" y="4105656"/>
-            <a:ext cx="4754880" cy="731520"/>
+            <a:off x="566928" y="3648456"/>
+            <a:ext cx="4754880" cy="621792"/>
           </a:xfrm>
           <a:prstGeom prst="roundRect">
             <a:avLst>
@@ -16453,7 +16470,7 @@
                 </a:solidFill>
                 <a:latin typeface="Arial"/>
               </a:rPr>
-              <a:t>Speaks Marathi, then Hindi</a:t>
+              <a:t>“Kitni baar call karoge!”</a:t>
             </a:r>
           </a:p>
         </p:txBody>
@@ -16466,14 +16483,14 @@
         </p:nvSpPr>
         <p:spPr>
           <a:xfrm>
-            <a:off x="5440680" y="4288536"/>
+            <a:off x="5440680" y="3776472"/>
             <a:ext cx="457200" cy="365760"/>
           </a:xfrm>
           <a:prstGeom prst="rightArrow">
             <a:avLst/>
           </a:prstGeom>
           <a:solidFill>
-            <a:srgbClr val="5B3E96"/>
+            <a:srgbClr val="C00000"/>
           </a:solidFill>
           <a:ln>
             <a:noFill/>
@@ -16509,8 +16526,8 @@
         </p:nvSpPr>
         <p:spPr>
           <a:xfrm>
-            <a:off x="6035040" y="4105656"/>
-            <a:ext cx="5577840" cy="731520"/>
+            <a:off x="6035040" y="3648456"/>
+            <a:ext cx="5577840" cy="621792"/>
           </a:xfrm>
           <a:prstGeom prst="roundRect">
             <a:avLst>
@@ -16518,7 +16535,7 @@
             </a:avLst>
           </a:prstGeom>
           <a:solidFill>
-            <a:srgbClr val="5B3E96"/>
+            <a:srgbClr val="C00000"/>
           </a:solidFill>
           <a:ln>
             <a:noFill/>
@@ -16555,7 +16572,7 @@
                 </a:solidFill>
                 <a:latin typeface="Arial"/>
               </a:rPr>
-              <a:t>Replies in the seller's language</a:t>
+              <a:t>Brief apology, stops the pitch</a:t>
             </a:r>
           </a:p>
         </p:txBody>
@@ -16568,8 +16585,8 @@
         </p:nvSpPr>
         <p:spPr>
           <a:xfrm>
-            <a:off x="566928" y="5001768"/>
-            <a:ext cx="4754880" cy="731520"/>
+            <a:off x="566928" y="4407408"/>
+            <a:ext cx="4754880" cy="621792"/>
           </a:xfrm>
           <a:prstGeom prst="roundRect">
             <a:avLst>
@@ -16616,7 +16633,7 @@
                 </a:solidFill>
                 <a:latin typeface="Arial"/>
               </a:rPr>
-              <a:t>“Who handles my account?”</a:t>
+              <a:t>Speaks Marathi, then Hindi</a:t>
             </a:r>
           </a:p>
         </p:txBody>
@@ -16629,7 +16646,170 @@
         </p:nvSpPr>
         <p:spPr>
           <a:xfrm>
-            <a:off x="5440680" y="5184648"/>
+            <a:off x="5440680" y="4535424"/>
+            <a:ext cx="457200" cy="365760"/>
+          </a:xfrm>
+          <a:prstGeom prst="rightArrow">
+            <a:avLst/>
+          </a:prstGeom>
+          <a:solidFill>
+            <a:srgbClr val="5B3E96"/>
+          </a:solidFill>
+          <a:ln>
+            <a:noFill/>
+          </a:ln>
+        </p:spPr>
+        <p:style>
+          <a:lnRef idx="1">
+            <a:schemeClr val="accent1"/>
+          </a:lnRef>
+          <a:fillRef idx="3">
+            <a:schemeClr val="accent1"/>
+          </a:fillRef>
+          <a:effectRef idx="2">
+            <a:schemeClr val="accent1"/>
+          </a:effectRef>
+          <a:fontRef idx="minor">
+            <a:schemeClr val="lt1"/>
+          </a:fontRef>
+        </p:style>
+        <p:txBody>
+          <a:bodyPr rtlCol="0" anchor="ctr"/>
+          <a:lstStyle/>
+          <a:p>
+            <a:pPr algn="ctr"/>
+          </a:p>
+        </p:txBody>
+      </p:sp>
+      <p:sp>
+        <p:nvSpPr>
+          <p:cNvPr id="17" name="Rounded Rectangle 16"/>
+          <p:cNvSpPr/>
+          <p:nvPr/>
+        </p:nvSpPr>
+        <p:spPr>
+          <a:xfrm>
+            <a:off x="6035040" y="4407408"/>
+            <a:ext cx="5577840" cy="621792"/>
+          </a:xfrm>
+          <a:prstGeom prst="roundRect">
+            <a:avLst>
+              <a:gd name="adj" fmla="val 40000"/>
+            </a:avLst>
+          </a:prstGeom>
+          <a:solidFill>
+            <a:srgbClr val="5B3E96"/>
+          </a:solidFill>
+          <a:ln>
+            <a:noFill/>
+          </a:ln>
+          <a:effectLst/>
+        </p:spPr>
+        <p:style>
+          <a:lnRef idx="1">
+            <a:schemeClr val="accent1"/>
+          </a:lnRef>
+          <a:fillRef idx="3">
+            <a:schemeClr val="accent1"/>
+          </a:fillRef>
+          <a:effectRef idx="2">
+            <a:schemeClr val="accent1"/>
+          </a:effectRef>
+          <a:fontRef idx="minor">
+            <a:schemeClr val="lt1"/>
+          </a:fontRef>
+        </p:style>
+        <p:txBody>
+          <a:bodyPr rtlCol="0" anchor="ctr" wrap="square" lIns="109728" rIns="109728" tIns="54864" bIns="54864"/>
+          <a:lstStyle/>
+          <a:p>
+            <a:pPr algn="l">
+              <a:spcAft>
+                <a:spcPts val="0"/>
+              </a:spcAft>
+            </a:pPr>
+            <a:r>
+              <a:rPr sz="1400" b="1">
+                <a:solidFill>
+                  <a:srgbClr val="FFFFFF"/>
+                </a:solidFill>
+                <a:latin typeface="Arial"/>
+              </a:rPr>
+              <a:t>Replies in the seller's language</a:t>
+            </a:r>
+          </a:p>
+        </p:txBody>
+      </p:sp>
+      <p:sp>
+        <p:nvSpPr>
+          <p:cNvPr id="18" name="Rounded Rectangle 17"/>
+          <p:cNvSpPr/>
+          <p:nvPr/>
+        </p:nvSpPr>
+        <p:spPr>
+          <a:xfrm>
+            <a:off x="566928" y="5166359"/>
+            <a:ext cx="4754880" cy="621792"/>
+          </a:xfrm>
+          <a:prstGeom prst="roundRect">
+            <a:avLst>
+              <a:gd name="adj" fmla="val 40000"/>
+            </a:avLst>
+          </a:prstGeom>
+          <a:solidFill>
+            <a:srgbClr val="EEF2F8"/>
+          </a:solidFill>
+          <a:ln w="12700">
+            <a:solidFill>
+              <a:srgbClr val="595959"/>
+            </a:solidFill>
+          </a:ln>
+          <a:effectLst/>
+        </p:spPr>
+        <p:style>
+          <a:lnRef idx="1">
+            <a:schemeClr val="accent1"/>
+          </a:lnRef>
+          <a:fillRef idx="3">
+            <a:schemeClr val="accent1"/>
+          </a:fillRef>
+          <a:effectRef idx="2">
+            <a:schemeClr val="accent1"/>
+          </a:effectRef>
+          <a:fontRef idx="minor">
+            <a:schemeClr val="lt1"/>
+          </a:fontRef>
+        </p:style>
+        <p:txBody>
+          <a:bodyPr rtlCol="0" anchor="ctr" wrap="square" lIns="109728" rIns="109728" tIns="54864" bIns="54864"/>
+          <a:lstStyle/>
+          <a:p>
+            <a:pPr algn="l">
+              <a:spcAft>
+                <a:spcPts val="0"/>
+              </a:spcAft>
+            </a:pPr>
+            <a:r>
+              <a:rPr sz="1400" b="0">
+                <a:solidFill>
+                  <a:srgbClr val="262626"/>
+                </a:solidFill>
+                <a:latin typeface="Arial"/>
+              </a:rPr>
+              <a:t>“Who handles my account?”</a:t>
+            </a:r>
+          </a:p>
+        </p:txBody>
+      </p:sp>
+      <p:sp>
+        <p:nvSpPr>
+          <p:cNvPr id="19" name="Right Arrow 18"/>
+          <p:cNvSpPr/>
+          <p:nvPr/>
+        </p:nvSpPr>
+        <p:spPr>
+          <a:xfrm>
+            <a:off x="5440680" y="5294375"/>
             <a:ext cx="457200" cy="365760"/>
           </a:xfrm>
           <a:prstGeom prst="rightArrow">
@@ -16666,14 +16846,14 @@
       </p:sp>
       <p:sp>
         <p:nvSpPr>
-          <p:cNvPr id="17" name="Rounded Rectangle 16"/>
+          <p:cNvPr id="20" name="Rounded Rectangle 19"/>
           <p:cNvSpPr/>
           <p:nvPr/>
         </p:nvSpPr>
         <p:spPr>
           <a:xfrm>
-            <a:off x="6035040" y="5001768"/>
-            <a:ext cx="5577840" cy="731520"/>
+            <a:off x="6035040" y="5166359"/>
+            <a:ext cx="5577840" cy="621792"/>
           </a:xfrm>
           <a:prstGeom prst="roundRect">
             <a:avLst>
@@ -16718,14 +16898,14 @@
                 </a:solidFill>
                 <a:latin typeface="Arial"/>
               </a:rPr>
-              <a:t>Names the executive, books the meeting with them</a:t>
+              <a:t>Names the handler and books with them; a team if none</a:t>
             </a:r>
           </a:p>
         </p:txBody>
       </p:sp>
       <p:sp>
         <p:nvSpPr>
-          <p:cNvPr id="18" name="TextBox 17"/>
+          <p:cNvPr id="21" name="TextBox 20"/>
           <p:cNvSpPr txBox="1"/>
           <p:nvPr/>
         </p:nvSpPr>
@@ -16764,7 +16944,7 @@
       </p:sp>
       <p:sp>
         <p:nvSpPr>
-          <p:cNvPr id="19" name="TextBox 18"/>
+          <p:cNvPr id="22" name="TextBox 21"/>
           <p:cNvSpPr txBox="1"/>
           <p:nvPr/>
         </p:nvSpPr>
@@ -17797,7 +17977,7 @@
                 </a:solidFill>
                 <a:latin typeface="Arial"/>
               </a:rPr>
-              <a:t>Safety rails: never AI, bot or manager  |  numbers only from verified facts  |  names stay tokens in the sandbox  |  no price on the call</a:t>
+              <a:t>Safety rails: never AI, bot or manager; never claims to be human  |  numbers only from verified facts  |  names stay tokens in the sandbox  |  no price on the call</a:t>
             </a:r>
           </a:p>
         </p:txBody>

</xml_diff>

<commit_message>
Deck: future goals without upselling; add objective per seller (meeting, enrichment, NPS), preferred call time, preferred language
Co-Authored-By: Claude Sonnet 5.5 <noreply@anthropic.com>
Claude-Session: https://claude.ai/code/session_011uVttPTSPum9783y8wvy9a
</commit_message>
<xml_diff>
--- a/outputs/plans/VANI_Persona_Design_Deck_v2_visual.pptx
+++ b/outputs/plans/VANI_Persona_Design_Deck_v2_visual.pptx
@@ -1392,7 +1392,7 @@
           <a:lstStyle/>
           <a:p>
             <a:r>
-              <a:t>Now: meeting arrangement. The right persona and hook per seller to book the executive meeting, with live adaptation. Next: seller enrichment. Catalogue improvement calls (photos, prices, categories) with suggestions drawn from the seller's top categories and similar sellers; a top-category hook; profile completion with the seller on the call. Later: selling higher packages. Upsell and renewal calls using credit usage, lead quality and peer proof, from the same persona engine. Platform: learning from real calls, more languages and voices, production telephony at scale (today the phone route reaches only whitelisted test numbers).</a:t>
+              <a:t>Now: meeting arrangement. The right persona and hook per seller to book the executive meeting, with live adaptation. Next: seller enrichment. Catalogue improvement calls (photos, prices, categories) with suggestions drawn from the seller's top categories and similar sellers; a top-category hook; profile completion with the seller on the call. Personalise further, per seller: (1) a personalised objective for the seller persona: the call goal itself is chosen per seller from meeting, enrichment or NPS (net promoter score); (2) a preferred call time per seller, to improve the share of calls that are answered (call scheduling is handled outside the persona today); (3) a preferred or suggested language per seller, from the seller's location, GST state and the languages heard on earlier calls. Platform: learning from real calls, more languages and voices, production telephony at scale (today the phone route reaches only whitelisted test numbers).</a:t>
             </a:r>
           </a:p>
         </p:txBody>
@@ -18023,70 +18023,14 @@
       </p:sp>
       <p:sp>
         <p:nvSpPr>
-          <p:cNvPr id="3" name="Oval 2"/>
+          <p:cNvPr id="3" name="Rounded Rectangle 2"/>
           <p:cNvSpPr/>
           <p:nvPr/>
         </p:nvSpPr>
         <p:spPr>
           <a:xfrm>
-            <a:off x="1755648" y="1554480"/>
-            <a:ext cx="1097280" cy="1097280"/>
-          </a:xfrm>
-          <a:prstGeom prst="ellipse">
-            <a:avLst/>
-          </a:prstGeom>
-          <a:solidFill>
-            <a:srgbClr val="C00000"/>
-          </a:solidFill>
-          <a:ln>
-            <a:noFill/>
-          </a:ln>
-        </p:spPr>
-        <p:style>
-          <a:lnRef idx="1">
-            <a:schemeClr val="accent1"/>
-          </a:lnRef>
-          <a:fillRef idx="3">
-            <a:schemeClr val="accent1"/>
-          </a:fillRef>
-          <a:effectRef idx="2">
-            <a:schemeClr val="accent1"/>
-          </a:effectRef>
-          <a:fontRef idx="minor">
-            <a:schemeClr val="lt1"/>
-          </a:fontRef>
-        </p:style>
-        <p:txBody>
-          <a:bodyPr rtlCol="0" anchor="ctr" lIns="0" rIns="0" tIns="0" bIns="0"/>
-          <a:lstStyle/>
-          <a:p>
-            <a:pPr algn="ctr">
-              <a:spcAft>
-                <a:spcPts val="0"/>
-              </a:spcAft>
-            </a:pPr>
-            <a:r>
-              <a:rPr sz="1800" b="1">
-                <a:solidFill>
-                  <a:srgbClr val="FFFFFF"/>
-                </a:solidFill>
-                <a:latin typeface="Arial"/>
-              </a:rPr>
-              <a:t>NOW</a:t>
-            </a:r>
-          </a:p>
-        </p:txBody>
-      </p:sp>
-      <p:sp>
-        <p:nvSpPr>
-          <p:cNvPr id="4" name="Rounded Rectangle 3"/>
-          <p:cNvSpPr/>
-          <p:nvPr/>
-        </p:nvSpPr>
-        <p:spPr>
-          <a:xfrm>
-            <a:off x="566928" y="2834640"/>
-            <a:ext cx="3383280" cy="1554480"/>
+            <a:off x="566928" y="1463040"/>
+            <a:ext cx="5212080" cy="1371600"/>
           </a:xfrm>
           <a:prstGeom prst="roundRect">
             <a:avLst>
@@ -18131,7 +18075,7 @@
                 </a:solidFill>
                 <a:latin typeface="Arial"/>
               </a:rPr>
-              <a:t>Meeting arrangement</a:t>
+              <a:t>NOW: Meeting arrangement</a:t>
             </a:r>
           </a:p>
           <a:p>
@@ -18154,14 +18098,14 @@
       </p:sp>
       <p:sp>
         <p:nvSpPr>
-          <p:cNvPr id="5" name="Right Arrow 4"/>
+          <p:cNvPr id="4" name="Right Arrow 3"/>
           <p:cNvSpPr/>
           <p:nvPr/>
         </p:nvSpPr>
         <p:spPr>
           <a:xfrm>
-            <a:off x="3995928" y="3383280"/>
-            <a:ext cx="365760" cy="411480"/>
+            <a:off x="5852160" y="1920240"/>
+            <a:ext cx="457200" cy="411480"/>
           </a:xfrm>
           <a:prstGeom prst="rightArrow">
             <a:avLst/>
@@ -18197,70 +18141,14 @@
       </p:sp>
       <p:sp>
         <p:nvSpPr>
-          <p:cNvPr id="6" name="Oval 5"/>
+          <p:cNvPr id="5" name="Rounded Rectangle 4"/>
           <p:cNvSpPr/>
           <p:nvPr/>
         </p:nvSpPr>
         <p:spPr>
           <a:xfrm>
-            <a:off x="5596128" y="1554480"/>
-            <a:ext cx="1097280" cy="1097280"/>
-          </a:xfrm>
-          <a:prstGeom prst="ellipse">
-            <a:avLst/>
-          </a:prstGeom>
-          <a:solidFill>
-            <a:srgbClr val="002060"/>
-          </a:solidFill>
-          <a:ln>
-            <a:noFill/>
-          </a:ln>
-        </p:spPr>
-        <p:style>
-          <a:lnRef idx="1">
-            <a:schemeClr val="accent1"/>
-          </a:lnRef>
-          <a:fillRef idx="3">
-            <a:schemeClr val="accent1"/>
-          </a:fillRef>
-          <a:effectRef idx="2">
-            <a:schemeClr val="accent1"/>
-          </a:effectRef>
-          <a:fontRef idx="minor">
-            <a:schemeClr val="lt1"/>
-          </a:fontRef>
-        </p:style>
-        <p:txBody>
-          <a:bodyPr rtlCol="0" anchor="ctr" lIns="0" rIns="0" tIns="0" bIns="0"/>
-          <a:lstStyle/>
-          <a:p>
-            <a:pPr algn="ctr">
-              <a:spcAft>
-                <a:spcPts val="0"/>
-              </a:spcAft>
-            </a:pPr>
-            <a:r>
-              <a:rPr sz="1800" b="1">
-                <a:solidFill>
-                  <a:srgbClr val="FFFFFF"/>
-                </a:solidFill>
-                <a:latin typeface="Arial"/>
-              </a:rPr>
-              <a:t>NEXT</a:t>
-            </a:r>
-          </a:p>
-        </p:txBody>
-      </p:sp>
-      <p:sp>
-        <p:nvSpPr>
-          <p:cNvPr id="7" name="Rounded Rectangle 6"/>
-          <p:cNvSpPr/>
-          <p:nvPr/>
-        </p:nvSpPr>
-        <p:spPr>
-          <a:xfrm>
-            <a:off x="4407408" y="2834640"/>
-            <a:ext cx="3383280" cy="1554480"/>
+            <a:off x="6400800" y="1463040"/>
+            <a:ext cx="5212080" cy="1371600"/>
           </a:xfrm>
           <a:prstGeom prst="roundRect">
             <a:avLst>
@@ -18305,7 +18193,7 @@
                 </a:solidFill>
                 <a:latin typeface="Arial"/>
               </a:rPr>
-              <a:t>Seller enrichment</a:t>
+              <a:t>NEXT: Seller enrichment</a:t>
             </a:r>
           </a:p>
           <a:p>
@@ -18328,24 +18216,68 @@
       </p:sp>
       <p:sp>
         <p:nvSpPr>
-          <p:cNvPr id="8" name="Right Arrow 7"/>
+          <p:cNvPr id="6" name="TextBox 5"/>
+          <p:cNvSpPr txBox="1"/>
+          <p:nvPr/>
+        </p:nvSpPr>
+        <p:spPr>
+          <a:xfrm>
+            <a:off x="566928" y="3154680"/>
+            <a:ext cx="10972800" cy="365760"/>
+          </a:xfrm>
+          <a:prstGeom prst="rect">
+            <a:avLst/>
+          </a:prstGeom>
+          <a:noFill/>
+        </p:spPr>
+        <p:txBody>
+          <a:bodyPr wrap="square">
+            <a:spAutoFit/>
+          </a:bodyPr>
+          <a:lstStyle/>
+          <a:p>
+            <a:pPr algn="l">
+              <a:spcAft>
+                <a:spcPts val="0"/>
+              </a:spcAft>
+            </a:pPr>
+            <a:r>
+              <a:rPr sz="1600" b="1">
+                <a:solidFill>
+                  <a:srgbClr val="5B3E96"/>
+                </a:solidFill>
+                <a:latin typeface="Arial"/>
+              </a:rPr>
+              <a:t>Personalise further, per seller</a:t>
+            </a:r>
+          </a:p>
+        </p:txBody>
+      </p:sp>
+      <p:sp>
+        <p:nvSpPr>
+          <p:cNvPr id="7" name="Rounded Rectangle 6"/>
           <p:cNvSpPr/>
           <p:nvPr/>
         </p:nvSpPr>
         <p:spPr>
           <a:xfrm>
-            <a:off x="7836408" y="3383280"/>
-            <a:ext cx="365760" cy="411480"/>
+            <a:off x="566928" y="3611880"/>
+            <a:ext cx="3566160" cy="1828800"/>
           </a:xfrm>
-          <a:prstGeom prst="rightArrow">
-            <a:avLst/>
+          <a:prstGeom prst="roundRect">
+            <a:avLst>
+              <a:gd name="adj" fmla="val 6000"/>
+            </a:avLst>
           </a:prstGeom>
           <a:solidFill>
-            <a:srgbClr val="595959"/>
+            <a:srgbClr val="FFFFFF"/>
           </a:solidFill>
-          <a:ln>
-            <a:noFill/>
+          <a:ln w="12700">
+            <a:solidFill>
+              <a:srgbClr val="2EA896"/>
+            </a:solidFill>
           </a:ln>
+          <a:effectLst/>
         </p:spPr>
         <p:style>
           <a:lnRef idx="1">
@@ -18362,23 +18294,52 @@
           </a:fontRef>
         </p:style>
         <p:txBody>
-          <a:bodyPr rtlCol="0" anchor="ctr"/>
+          <a:bodyPr rtlCol="0" anchor="ctr" wrap="square" lIns="1005840" rIns="109728" tIns="54864" bIns="54864"/>
           <a:lstStyle/>
           <a:p>
-            <a:pPr algn="ctr"/>
+            <a:pPr algn="l">
+              <a:spcAft>
+                <a:spcPts val="300"/>
+              </a:spcAft>
+            </a:pPr>
+            <a:r>
+              <a:rPr sz="1600" b="1">
+                <a:solidFill>
+                  <a:srgbClr val="2EA896"/>
+                </a:solidFill>
+                <a:latin typeface="Arial"/>
+              </a:rPr>
+              <a:t>Objective per seller</a:t>
+            </a:r>
+          </a:p>
+          <a:p>
+            <a:pPr algn="l">
+              <a:spcAft>
+                <a:spcPts val="0"/>
+              </a:spcAft>
+            </a:pPr>
+            <a:r>
+              <a:rPr sz="1300" b="0">
+                <a:solidFill>
+                  <a:srgbClr val="262626"/>
+                </a:solidFill>
+                <a:latin typeface="Arial"/>
+              </a:rPr>
+              <a:t>Meeting, enrichment or NPS</a:t>
+            </a:r>
           </a:p>
         </p:txBody>
       </p:sp>
       <p:sp>
         <p:nvSpPr>
-          <p:cNvPr id="9" name="Oval 8"/>
+          <p:cNvPr id="8" name="Oval 7"/>
           <p:cNvSpPr/>
           <p:nvPr/>
         </p:nvSpPr>
         <p:spPr>
           <a:xfrm>
-            <a:off x="9436608" y="1554480"/>
-            <a:ext cx="1097280" cy="1097280"/>
+            <a:off x="749808" y="3794760"/>
+            <a:ext cx="640080" cy="640080"/>
           </a:xfrm>
           <a:prstGeom prst="ellipse">
             <a:avLst/>
@@ -18414,27 +18375,27 @@
               </a:spcAft>
             </a:pPr>
             <a:r>
-              <a:rPr sz="1800" b="1">
+              <a:rPr sz="2000" b="1">
                 <a:solidFill>
                   <a:srgbClr val="FFFFFF"/>
                 </a:solidFill>
                 <a:latin typeface="Arial"/>
               </a:rPr>
-              <a:t>LATER</a:t>
+              <a:t>1</a:t>
             </a:r>
           </a:p>
         </p:txBody>
       </p:sp>
       <p:sp>
         <p:nvSpPr>
-          <p:cNvPr id="10" name="Rounded Rectangle 9"/>
+          <p:cNvPr id="9" name="Rounded Rectangle 8"/>
           <p:cNvSpPr/>
           <p:nvPr/>
         </p:nvSpPr>
         <p:spPr>
           <a:xfrm>
-            <a:off x="8247888" y="2834640"/>
-            <a:ext cx="3383280" cy="1554480"/>
+            <a:off x="4407408" y="3611880"/>
+            <a:ext cx="3566160" cy="1828800"/>
           </a:xfrm>
           <a:prstGeom prst="roundRect">
             <a:avLst>
@@ -18442,10 +18403,12 @@
             </a:avLst>
           </a:prstGeom>
           <a:solidFill>
-            <a:srgbClr val="2EA896"/>
+            <a:srgbClr val="FFFFFF"/>
           </a:solidFill>
-          <a:ln>
-            <a:noFill/>
+          <a:ln w="12700">
+            <a:solidFill>
+              <a:srgbClr val="E08A00"/>
+            </a:solidFill>
           </a:ln>
           <a:effectLst/>
         </p:spPr>
@@ -18464,26 +18427,26 @@
           </a:fontRef>
         </p:style>
         <p:txBody>
-          <a:bodyPr rtlCol="0" anchor="ctr" wrap="square" lIns="109728" rIns="109728" tIns="54864" bIns="54864"/>
+          <a:bodyPr rtlCol="0" anchor="ctr" wrap="square" lIns="1005840" rIns="109728" tIns="54864" bIns="54864"/>
           <a:lstStyle/>
           <a:p>
-            <a:pPr algn="ctr">
-              <a:spcAft>
-                <a:spcPts val="200"/>
+            <a:pPr algn="l">
+              <a:spcAft>
+                <a:spcPts val="300"/>
               </a:spcAft>
             </a:pPr>
             <a:r>
-              <a:rPr sz="1700" b="1">
-                <a:solidFill>
-                  <a:srgbClr val="FFFFFF"/>
+              <a:rPr sz="1600" b="1">
+                <a:solidFill>
+                  <a:srgbClr val="E08A00"/>
                 </a:solidFill>
                 <a:latin typeface="Arial"/>
               </a:rPr>
-              <a:t>Higher packages</a:t>
+              <a:t>Preferred call time</a:t>
             </a:r>
           </a:p>
           <a:p>
-            <a:pPr algn="ctr">
+            <a:pPr algn="l">
               <a:spcAft>
                 <a:spcPts val="0"/>
               </a:spcAft>
@@ -18491,35 +18454,52 @@
             <a:r>
               <a:rPr sz="1300" b="0">
                 <a:solidFill>
-                  <a:srgbClr val="FFFFFF"/>
+                  <a:srgbClr val="262626"/>
                 </a:solidFill>
                 <a:latin typeface="Arial"/>
               </a:rPr>
-              <a:t>Upsell and renewal, same engine</a:t>
+              <a:t>More calls answered</a:t>
             </a:r>
           </a:p>
         </p:txBody>
       </p:sp>
       <p:sp>
         <p:nvSpPr>
-          <p:cNvPr id="11" name="TextBox 10"/>
-          <p:cNvSpPr txBox="1"/>
+          <p:cNvPr id="10" name="Oval 9"/>
+          <p:cNvSpPr/>
           <p:nvPr/>
         </p:nvSpPr>
         <p:spPr>
           <a:xfrm>
-            <a:off x="566928" y="4846320"/>
-            <a:ext cx="10972800" cy="457200"/>
+            <a:off x="4590288" y="3794760"/>
+            <a:ext cx="640080" cy="640080"/>
           </a:xfrm>
-          <a:prstGeom prst="rect">
+          <a:prstGeom prst="ellipse">
             <a:avLst/>
           </a:prstGeom>
-          <a:noFill/>
+          <a:solidFill>
+            <a:srgbClr val="E08A00"/>
+          </a:solidFill>
+          <a:ln>
+            <a:noFill/>
+          </a:ln>
         </p:spPr>
+        <p:style>
+          <a:lnRef idx="1">
+            <a:schemeClr val="accent1"/>
+          </a:lnRef>
+          <a:fillRef idx="3">
+            <a:schemeClr val="accent1"/>
+          </a:fillRef>
+          <a:effectRef idx="2">
+            <a:schemeClr val="accent1"/>
+          </a:effectRef>
+          <a:fontRef idx="minor">
+            <a:schemeClr val="lt1"/>
+          </a:fontRef>
+        </p:style>
         <p:txBody>
-          <a:bodyPr wrap="square">
-            <a:spAutoFit/>
-          </a:bodyPr>
+          <a:bodyPr rtlCol="0" anchor="ctr" lIns="0" rIns="0" tIns="0" bIns="0"/>
           <a:lstStyle/>
           <a:p>
             <a:pPr algn="ctr">
@@ -18528,13 +18508,146 @@
               </a:spcAft>
             </a:pPr>
             <a:r>
-              <a:rPr sz="1400" b="0">
-                <a:solidFill>
-                  <a:srgbClr val="595959"/>
+              <a:rPr sz="2000" b="1">
+                <a:solidFill>
+                  <a:srgbClr val="FFFFFF"/>
                 </a:solidFill>
                 <a:latin typeface="Arial"/>
               </a:rPr>
-              <a:t>More languages and voices  |  learning from real calls  |  production telephony</a:t>
+              <a:t>2</a:t>
+            </a:r>
+          </a:p>
+        </p:txBody>
+      </p:sp>
+      <p:sp>
+        <p:nvSpPr>
+          <p:cNvPr id="11" name="Rounded Rectangle 10"/>
+          <p:cNvSpPr/>
+          <p:nvPr/>
+        </p:nvSpPr>
+        <p:spPr>
+          <a:xfrm>
+            <a:off x="8247888" y="3611880"/>
+            <a:ext cx="3566160" cy="1828800"/>
+          </a:xfrm>
+          <a:prstGeom prst="roundRect">
+            <a:avLst>
+              <a:gd name="adj" fmla="val 6000"/>
+            </a:avLst>
+          </a:prstGeom>
+          <a:solidFill>
+            <a:srgbClr val="FFFFFF"/>
+          </a:solidFill>
+          <a:ln w="12700">
+            <a:solidFill>
+              <a:srgbClr val="5B3E96"/>
+            </a:solidFill>
+          </a:ln>
+          <a:effectLst/>
+        </p:spPr>
+        <p:style>
+          <a:lnRef idx="1">
+            <a:schemeClr val="accent1"/>
+          </a:lnRef>
+          <a:fillRef idx="3">
+            <a:schemeClr val="accent1"/>
+          </a:fillRef>
+          <a:effectRef idx="2">
+            <a:schemeClr val="accent1"/>
+          </a:effectRef>
+          <a:fontRef idx="minor">
+            <a:schemeClr val="lt1"/>
+          </a:fontRef>
+        </p:style>
+        <p:txBody>
+          <a:bodyPr rtlCol="0" anchor="ctr" wrap="square" lIns="1005840" rIns="109728" tIns="54864" bIns="54864"/>
+          <a:lstStyle/>
+          <a:p>
+            <a:pPr algn="l">
+              <a:spcAft>
+                <a:spcPts val="300"/>
+              </a:spcAft>
+            </a:pPr>
+            <a:r>
+              <a:rPr sz="1600" b="1">
+                <a:solidFill>
+                  <a:srgbClr val="5B3E96"/>
+                </a:solidFill>
+                <a:latin typeface="Arial"/>
+              </a:rPr>
+              <a:t>Preferred language</a:t>
+            </a:r>
+          </a:p>
+          <a:p>
+            <a:pPr algn="l">
+              <a:spcAft>
+                <a:spcPts val="0"/>
+              </a:spcAft>
+            </a:pPr>
+            <a:r>
+              <a:rPr sz="1300" b="0">
+                <a:solidFill>
+                  <a:srgbClr val="262626"/>
+                </a:solidFill>
+                <a:latin typeface="Arial"/>
+              </a:rPr>
+              <a:t>Suggested from the seller's data</a:t>
+            </a:r>
+          </a:p>
+        </p:txBody>
+      </p:sp>
+      <p:sp>
+        <p:nvSpPr>
+          <p:cNvPr id="12" name="Oval 11"/>
+          <p:cNvSpPr/>
+          <p:nvPr/>
+        </p:nvSpPr>
+        <p:spPr>
+          <a:xfrm>
+            <a:off x="8430767" y="3794760"/>
+            <a:ext cx="640080" cy="640080"/>
+          </a:xfrm>
+          <a:prstGeom prst="ellipse">
+            <a:avLst/>
+          </a:prstGeom>
+          <a:solidFill>
+            <a:srgbClr val="5B3E96"/>
+          </a:solidFill>
+          <a:ln>
+            <a:noFill/>
+          </a:ln>
+        </p:spPr>
+        <p:style>
+          <a:lnRef idx="1">
+            <a:schemeClr val="accent1"/>
+          </a:lnRef>
+          <a:fillRef idx="3">
+            <a:schemeClr val="accent1"/>
+          </a:fillRef>
+          <a:effectRef idx="2">
+            <a:schemeClr val="accent1"/>
+          </a:effectRef>
+          <a:fontRef idx="minor">
+            <a:schemeClr val="lt1"/>
+          </a:fontRef>
+        </p:style>
+        <p:txBody>
+          <a:bodyPr rtlCol="0" anchor="ctr" lIns="0" rIns="0" tIns="0" bIns="0"/>
+          <a:lstStyle/>
+          <a:p>
+            <a:pPr algn="ctr">
+              <a:spcAft>
+                <a:spcPts val="0"/>
+              </a:spcAft>
+            </a:pPr>
+            <a:r>
+              <a:rPr sz="2000" b="1">
+                <a:solidFill>
+                  <a:srgbClr val="FFFFFF"/>
+                </a:solidFill>
+                <a:latin typeface="Arial"/>
+              </a:rPr>
+              <a:t>3</a:t>
             </a:r>
           </a:p>
         </p:txBody>

</xml_diff>

<commit_message>
Deck: mood decision strip (keyword tool in-call plus Jev decision model for labelling and checks), notes updated
Co-Authored-By: Claude Sonnet 5.5 <noreply@anthropic.com>
Claude-Session: https://claude.ai/code/session_011uVttPTSPum9783y8wvy9a
</commit_message>
<xml_diff>
--- a/outputs/plans/VANI_Persona_Design_Deck_v2_visual.pptx
+++ b/outputs/plans/VANI_Persona_Design_Deck_v2_visual.pptx
@@ -1276,7 +1276,7 @@
           <a:lstStyle/>
           <a:p>
             <a:r>
-              <a:t>Examples of the live signal tool at work. Every seller turn is read; the tool returns a mode (rushed, frustrated, confused, interested, declined, bot question, opt-out, language switch; question and handler questions as one-turn overlays) and a directive. In scripted test calls every switch type fired on the same turn, including a language switch from Marathi to Hindi to English. A switch log row records: turn, utterance, from mode, to mode, cue, directive id, change made, reason, whether asking for the meeting is allowed, milliseconds. Honest limits: voice, pace and pitch cannot change mid-call (a Sarvam platform limit), tone changes through wording; the keyword classifier is a baseline with about 0.60 measured accuracy on a small reviewed set, presented as a measurement not a production figure; a slower external classifier (Jev) was parked because of latency. Handler: with a handler name VANI says the name and books with that person; with a pool it says 'our IndiaMART team handles your account; the executive will introduce themselves when they call' and never a made-up name. 'Nahi chahiye' keeps the call open and restates the hook.</a:t>
+              <a:t>Examples of the live signal tool at work. Every seller turn is read; the tool returns a mode (rushed, frustrated, confused, interested, declined, bot question, opt-out, language switch; question and handler questions as one-turn overlays) and a directive. In scripted test calls every switch type fired on the same turn, including a language switch from Marathi to Hindi to English. A switch log row records: turn, utterance, from mode, to mode, cue, directive id, change made, reason, whether asking for the meeting is allowed, milliseconds. Honest limits: voice, pace and pitch cannot change mid-call (a Sarvam platform limit), tone changes through wording; the instant keyword classifier is a baseline with about 0.60 measured accuracy on a small reviewed set, presented as a measurement not a production figure. Jev (typesafe jev-1.13, a decision model reached through OpenRouter) judges mood with six questions (rushed, frustrated, confused, bot question, interested, language) in one request, about 0.5 s at the median; it was tested in live scripted calls through a relay, and it labels real call turns that score and improve the keyword tool between runs. Because its network round trip adds about 0.5 s to a spoken reply, in live calls it is used on fewer turns for now and the instant keyword tool answers first. Handler: with a handler name VANI says the name and books with that person; with a pool it says 'our IndiaMART team handles your account; the executive will introduce themselves when they call' and never a made-up name. 'Nahi chahiye' keeps the call open and restates the hook.</a:t>
             </a:r>
           </a:p>
         </p:txBody>
@@ -15882,6 +15882,67 @@
                 <a:latin typeface="Arial"/>
               </a:rPr>
               <a:t>The improvement loop feeds the next call's persona and hook</a:t>
+            </a:r>
+          </a:p>
+        </p:txBody>
+      </p:sp>
+      <p:sp>
+        <p:nvSpPr>
+          <p:cNvPr id="16" name="Rounded Rectangle 15"/>
+          <p:cNvSpPr/>
+          <p:nvPr/>
+        </p:nvSpPr>
+        <p:spPr>
+          <a:xfrm>
+            <a:off x="502920" y="5440680"/>
+            <a:ext cx="11338560" cy="594360"/>
+          </a:xfrm>
+          <a:prstGeom prst="roundRect">
+            <a:avLst>
+              <a:gd name="adj" fmla="val 30000"/>
+            </a:avLst>
+          </a:prstGeom>
+          <a:solidFill>
+            <a:srgbClr val="FFFFFF"/>
+          </a:solidFill>
+          <a:ln w="12700">
+            <a:solidFill>
+              <a:srgbClr val="2EA896"/>
+            </a:solidFill>
+          </a:ln>
+          <a:effectLst/>
+        </p:spPr>
+        <p:style>
+          <a:lnRef idx="1">
+            <a:schemeClr val="accent1"/>
+          </a:lnRef>
+          <a:fillRef idx="3">
+            <a:schemeClr val="accent1"/>
+          </a:fillRef>
+          <a:effectRef idx="2">
+            <a:schemeClr val="accent1"/>
+          </a:effectRef>
+          <a:fontRef idx="minor">
+            <a:schemeClr val="lt1"/>
+          </a:fontRef>
+        </p:style>
+        <p:txBody>
+          <a:bodyPr rtlCol="0" anchor="ctr" wrap="square" lIns="109728" rIns="109728" tIns="54864" bIns="54864"/>
+          <a:lstStyle/>
+          <a:p>
+            <a:pPr algn="ctr">
+              <a:spcAft>
+                <a:spcPts val="0"/>
+              </a:spcAft>
+            </a:pPr>
+            <a:r>
+              <a:rPr sz="1200" b="1">
+                <a:solidFill>
+                  <a:srgbClr val="002060"/>
+                </a:solidFill>
+                <a:latin typeface="Arial"/>
+              </a:rPr>
+              <a:t>Mood decision: instant keyword tool in-call, plus Jev decision model (6 mood questions, ~0.5 s) to label real calls and check the tool</a:t>
             </a:r>
           </a:p>
         </p:txBody>

</xml_diff>

<commit_message>
Deck slide 10: keyword tool decides in the call; Jev judges the same turns after the call (accuracy fix)
Co-Authored-By: Claude Sonnet 5.5 <noreply@anthropic.com>
Claude-Session: https://claude.ai/code/session_011uVttPTSPum9783y8wvy9a
</commit_message>
<xml_diff>
--- a/outputs/plans/VANI_Persona_Design_Deck_v2_visual.pptx
+++ b/outputs/plans/VANI_Persona_Design_Deck_v2_visual.pptx
@@ -1337,7 +1337,7 @@
           <a:lstStyle/>
           <a:p>
             <a:r>
-              <a:t>Examples of the live signal tool at work. Every seller turn is read; the tool returns a mode (rushed, frustrated, confused, interested, declined, bot question, opt-out, language switch; question and handler questions as one-turn overlays) and a directive. In scripted test calls every switch type fired on the same turn, including a language switch from Marathi to Hindi to English. A switch log row records: turn, utterance, from mode, to mode, cue, directive id, change made, reason, whether asking for the meeting is allowed, milliseconds. Honest limits: voice, pace and pitch cannot change mid-call (a Sarvam platform limit), tone changes through wording; the instant keyword classifier is a baseline with about 0.60 measured accuracy on a small reviewed set, presented as a measurement not a production figure. Jev (typesafe jev-1.13, a decision model reached through OpenRouter) judges mood with six questions (rushed, frustrated, confused, bot question, interested, language) in one request, about 0.5 s at the median; it was tested in live scripted calls through a relay, and it labels real call turns that score and improve the keyword tool between runs. Because its network round trip adds about 0.5 s to a spoken reply, in live calls it is used on fewer turns for now and the instant keyword tool answers first. Handler: with a handler name VANI says the name and books with that person; with a pool it says 'our IndiaMART team handles your account; the executive will introduce themselves when they call' and never a made-up name. 'Nahi chahiye' keeps the call open and restates the hook.</a:t>
+              <a:t>Examples of the live signal tool at work. Every seller turn is read; the tool returns a mode (rushed, frustrated, confused, interested, declined, bot question, opt-out, language switch; question and handler questions as one-turn overlays) and a directive. In scripted test calls every switch type fired on the same turn, including a language switch from Marathi to Hindi to English. A switch log row records: turn, utterance, from mode, to mode, cue, directive id, change made, reason, whether asking for the meeting is allowed, milliseconds. Honest limits: voice, pace and pitch cannot change mid-call (a Sarvam platform limit), tone changes through wording; the instant keyword classifier is a baseline with about 0.60 measured accuracy on a small reviewed set, presented as a measurement not a production figure. Jev (typesafe jev-1.13, a decision model reached through OpenRouter) judges mood with six questions (rushed, frustrated, confused, bot question, interested, language) in one request, about 0.5 s at the median; it was tested in live scripted calls through a relay, and it labels real call turns that score and improve the keyword tool between runs. In the live call the instant keyword tool decides, because the network round trip adds about 0.5 s to a spoken reply; Jev runs on real calls after the call. Handler: with a handler name VANI says the name and books with that person; with a pool it says 'our IndiaMART team handles your account; the executive will introduce themselves when they call' and never a made-up name. 'Nahi chahiye' keeps the call open and restates the hook.</a:t>
             </a:r>
           </a:p>
         </p:txBody>
@@ -1395,7 +1395,7 @@
           <a:lstStyle/>
           <a:p>
             <a:r>
-              <a:t>Two layers decide the seller's mood. Layer 1, the keyword tool, runs inside the Sarvam call on every seller turn in well under a millisecond, so the directive applies on the same turn; its measured accuracy is about 0.60 on a small reviewed set, presented as a measurement. Layer 2, Jev (typesafe jev-1.13, a decision model reached through OpenRouter), answers six yes/no mood questions in one request (rushed, frustrated, confused, bot question, interested, language) with a probability for each; about 0.5 s at the median, a tiny fraction of a cent per turn; 49 of 51 correct on a native-script test set and 10 of 10 on a tricky set; it catches cases the keywords miss, such as an irritated 'I am asking again, tell me the price or I hang up'. Jev labels real call turns, which scores and improves the keyword tool between runs (the gold set), and we tested it in live scripted calls through a relay. A web call adds about 0.5 s to a spoken reply, so in live calls it is used on fewer turns for now and the instant keyword tool answers first; a hybrid that asks Jev only on unclear turns within a strict time budget is the next step. We also evaluated a Sarvam chat model, a small trained classifier and fast hosted models, and measured their latency before choosing this design.</a:t>
+              <a:t>Two layers decide the seller's mood. Layer 1, the keyword tool, runs inside the Sarvam call on every seller turn in well under a millisecond, so the directive applies on the same turn; its measured accuracy is about 0.60 on a small reviewed set, presented as a measurement. Layer 2, Jev (typesafe jev-1.13, a decision model reached through OpenRouter), answers six yes/no mood questions in one request (rushed, frustrated, confused, bot question, interested, language) with a probability for each; about 0.5 s at the median, a tiny fraction of a cent per turn; 49 of 51 correct on a native-script test set and 10 of 10 on a tricky set; it catches cases the keywords miss, such as an irritated 'I am asking again, tell me the price or I hang up'. Jev labels real call turns, which scores and improves the keyword tool between runs (the gold set), and we tested it in live scripted calls through a relay. In the live call the instant keyword tool decides, because a web call to Jev adds about 0.5 s to a spoken reply; Jev runs on real calls after the call and was tested live through a relay. A hybrid that asks Jev only on unclear turns within a strict time budget is the next step. We also evaluated a Sarvam chat model, a small trained classifier and fast hosted models, and measured their latency before choosing this design.</a:t>
             </a:r>
           </a:p>
         </p:txBody>
@@ -19196,7 +19196,7 @@
                 </a:solidFill>
                 <a:latin typeface="Arial"/>
               </a:rPr>
-              <a:t>Jev decision model</a:t>
+              <a:t>Jev decision model: after the call</a:t>
             </a:r>
           </a:p>
           <a:p>
@@ -19212,7 +19212,7 @@
                 </a:solidFill>
                 <a:latin typeface="Arial"/>
               </a:rPr>
-              <a:t>6 mood questions at once: rushed, frustrated, confused, bot, interested, language</a:t>
+              <a:t>Judges the same turns on real calls: 6 mood questions at once</a:t>
             </a:r>
           </a:p>
           <a:p>
@@ -19228,7 +19228,7 @@
                 </a:solidFill>
                 <a:latin typeface="Arial"/>
               </a:rPr>
-              <a:t>About 0.5 s; 49 of 51 correct in tests</a:t>
+              <a:t>49 of 51 correct in tests; tested live via a relay</a:t>
             </a:r>
           </a:p>
         </p:txBody>
@@ -19327,8 +19327,8 @@
         </p:nvSpPr>
         <p:spPr>
           <a:xfrm>
-            <a:off x="8321040" y="2377440"/>
-            <a:ext cx="3383280" cy="2194560"/>
+            <a:off x="8321040" y="1371600"/>
+            <a:ext cx="3383280" cy="1737360"/>
           </a:xfrm>
           <a:prstGeom prst="roundRect">
             <a:avLst>
@@ -19389,7 +19389,7 @@
                 </a:solidFill>
                 <a:latin typeface="Arial"/>
               </a:rPr>
-              <a:t>rushed, confused, frustrated, interested, language switch, opt-out</a:t>
+              <a:t>in the call, same turn</a:t>
             </a:r>
           </a:p>
           <a:p>
@@ -19413,6 +19413,97 @@
       <p:sp>
         <p:nvSpPr>
           <p:cNvPr id="11" name="Rounded Rectangle 10"/>
+          <p:cNvSpPr/>
+          <p:nvPr/>
+        </p:nvSpPr>
+        <p:spPr>
+          <a:xfrm>
+            <a:off x="8321040" y="3474720"/>
+            <a:ext cx="3383280" cy="1737360"/>
+          </a:xfrm>
+          <a:prstGeom prst="roundRect">
+            <a:avLst>
+              <a:gd name="adj" fmla="val 6000"/>
+            </a:avLst>
+          </a:prstGeom>
+          <a:solidFill>
+            <a:srgbClr val="5B3E96"/>
+          </a:solidFill>
+          <a:ln>
+            <a:noFill/>
+          </a:ln>
+          <a:effectLst/>
+        </p:spPr>
+        <p:style>
+          <a:lnRef idx="1">
+            <a:schemeClr val="accent1"/>
+          </a:lnRef>
+          <a:fillRef idx="3">
+            <a:schemeClr val="accent1"/>
+          </a:fillRef>
+          <a:effectRef idx="2">
+            <a:schemeClr val="accent1"/>
+          </a:effectRef>
+          <a:fontRef idx="minor">
+            <a:schemeClr val="lt1"/>
+          </a:fontRef>
+        </p:style>
+        <p:txBody>
+          <a:bodyPr rtlCol="0" anchor="ctr" wrap="square" lIns="109728" rIns="109728" tIns="54864" bIns="54864"/>
+          <a:lstStyle/>
+          <a:p>
+            <a:pPr algn="ctr">
+              <a:spcAft>
+                <a:spcPts val="400"/>
+              </a:spcAft>
+            </a:pPr>
+            <a:r>
+              <a:rPr sz="1600" b="1">
+                <a:solidFill>
+                  <a:srgbClr val="FFFFFF"/>
+                </a:solidFill>
+                <a:latin typeface="Arial"/>
+              </a:rPr>
+              <a:t>LABELS</a:t>
+            </a:r>
+          </a:p>
+          <a:p>
+            <a:pPr algn="ctr">
+              <a:spcAft>
+                <a:spcPts val="400"/>
+              </a:spcAft>
+            </a:pPr>
+            <a:r>
+              <a:rPr sz="1100" b="0">
+                <a:solidFill>
+                  <a:srgbClr val="FFFFFF"/>
+                </a:solidFill>
+                <a:latin typeface="Arial"/>
+              </a:rPr>
+              <a:t>after the call</a:t>
+            </a:r>
+          </a:p>
+          <a:p>
+            <a:pPr algn="ctr">
+              <a:spcAft>
+                <a:spcPts val="0"/>
+              </a:spcAft>
+            </a:pPr>
+            <a:r>
+              <a:rPr sz="1200" b="1">
+                <a:solidFill>
+                  <a:srgbClr val="FFFFFF"/>
+                </a:solidFill>
+                <a:latin typeface="Arial"/>
+              </a:rPr>
+              <a:t>score and improve the keyword tool</a:t>
+            </a:r>
+          </a:p>
+        </p:txBody>
+      </p:sp>
+      <p:sp>
+        <p:nvSpPr>
+          <p:cNvPr id="12" name="Rounded Rectangle 11"/>
           <p:cNvSpPr/>
           <p:nvPr/>
         </p:nvSpPr>
@@ -19466,7 +19557,7 @@
                 </a:solidFill>
                 <a:latin typeface="Arial"/>
               </a:rPr>
-              <a:t>Jev also labels real calls: it scores and improves the keyword tool between runs</a:t>
+              <a:t>Keyword tool answers in the call; Jev judges the same turns after the call and teaches it</a:t>
             </a:r>
           </a:p>
         </p:txBody>

</xml_diff>

<commit_message>
Deck and doc v6: Jev runs between calls (not after); drop laptop wording
Co-Authored-By: Claude Sonnet 5.5 <noreply@anthropic.com>
Claude-Session: https://claude.ai/code/session_011uVttPTSPum9783y8wvy9a
</commit_message>
<xml_diff>
--- a/outputs/plans/VANI_Persona_Design_Deck_v2_visual.pptx
+++ b/outputs/plans/VANI_Persona_Design_Deck_v2_visual.pptx
@@ -1059,7 +1059,7 @@
           <a:lstStyle/>
           <a:p>
             <a:r>
-              <a:t>For each seller we collect 62 data points from about 60 IndiaMART sources: their business, their catalogue gaps, live buy leads, their competitors, how past calls went. Each data point can give VANI a reason for the meeting. Before the model sees the data we remove all personal data: names become tokens, and phone, GST and PAN numbers never leave IndiaMART (a hard check refuses any export that still holds one; real names are put back only on the laptop, for the voice call). About 53 of the 62 data points are filled for an average seller; the count of sources is approximate. The groups: identity (company, contact, designation; recorded gender only chooses the voice and is never said); location and language (city, state, GST state, onboarding cities, city tier, Hindi belt, languages heard on calls); business (plan free or paid, member since, turnover band, nature, profile text, company page); catalogue (top categories, product counts, quality score, products without photo or price, top five categories by active products); demand and money (buy leads bought, credits and lapse, rejection reasons, category value, seller order value, same-size peers, showcase leads, competitor list with plan); enquiries and channels; relationship (assigned sales handler, complaints, executive contact, do-not-call and frustration flags); past VANI calls with mood signals and objections. Size labels: below 40 lakh small, 40 lakh to 1.5 crore medium, 1.5 to 5 crore medium-high, 5 crore and above high. Plan: free is NSD, paid is CSD, TMW, KCD and other paid divisions.</a:t>
+              <a:t>For each seller we collect 62 data points from about 60 IndiaMART sources: their business, their catalogue gaps, live buy leads, their competitors, how past calls went. Each data point can give VANI a reason for the meeting. Before the model sees the data we remove all personal data: names become tokens, and phone, GST and PAN numbers never leave IndiaMART (a hard check refuses any export that still holds one; real names are put back only at call time, for the voice). About 53 of the 62 data points are filled for an average seller; the count of sources is approximate. The groups: identity (company, contact, designation; recorded gender only chooses the voice and is never said); location and language (city, state, GST state, onboarding cities, city tier, Hindi belt, languages heard on calls); business (plan free or paid, member since, turnover band, nature, profile text, company page); catalogue (top categories, product counts, quality score, products without photo or price, top five categories by active products); demand and money (buy leads bought, credits and lapse, rejection reasons, category value, seller order value, same-size peers, showcase leads, competitor list with plan); enquiries and channels; relationship (assigned sales handler, complaints, executive contact, do-not-call and frustration flags); past VANI calls with mood signals and objections. Size labels: below 40 lakh small, 40 lakh to 1.5 crore medium, 1.5 to 5 crore medium-high, 5 crore and above high. Plan: free is NSD, paid is CSD, TMW, KCD and other paid divisions.</a:t>
             </a:r>
           </a:p>
         </p:txBody>
@@ -1465,7 +1465,7 @@
           <a:lstStyle/>
           <a:p>
             <a:r>
-              <a:t>Examples of the live signal tool at work. Every seller turn is read; the tool returns a mode (rushed, frustrated, confused, interested, declined, bot question, opt-out, language switch; question and handler questions as one-turn overlays) and a directive. In scripted test calls every switch type fired on the same turn, including a language switch from Marathi to Hindi to English. A switch log row records: turn, utterance, from mode, to mode, cue, directive id, change made, reason, whether asking for the meeting is allowed, milliseconds. Honest limits: voice, pace and pitch cannot change mid-call (a Sarvam platform limit), tone changes through wording; the instant keyword classifier is a baseline with about 0.60 measured accuracy on a small reviewed set, presented as a measurement not a production figure. Jev (typesafe jev-1.13, a decision model reached through OpenRouter) judges mood with six questions (rushed, frustrated, confused, bot question, interested, language) in one request, about 0.5 s at the median; it was tested in live scripted calls through a relay, and it labels real call turns that score and improve the keyword tool between runs. In the live call the instant keyword tool decides, because the network round trip adds about 0.5 s to a spoken reply; Jev runs on real calls after the call. Handler: with a handler name VANI says the name and books with that person; with a pool it says 'our IndiaMART team handles your account; the executive will introduce themselves when they call' and never a made-up name. 'Nahi chahiye' keeps the call open and restates the hook.</a:t>
+              <a:t>Examples of the live signal tool at work. Every seller turn is read; the tool returns a mode (rushed, frustrated, confused, interested, declined, bot question, opt-out, language switch; question and handler questions as one-turn overlays) and a directive. In scripted test calls every switch type fired on the same turn, including a language switch from Marathi to Hindi to English. A switch log row records: turn, utterance, from mode, to mode, cue, directive id, change made, reason, whether asking for the meeting is allowed, milliseconds. Honest limits: voice, pace and pitch cannot change mid-call (a Sarvam platform limit), tone changes through wording; the instant keyword classifier is a baseline with about 0.60 measured accuracy on a small reviewed set, presented as a measurement not a production figure. Jev (typesafe jev-1.13, a decision model reached through OpenRouter) judges mood with six questions (rushed, frustrated, confused, bot question, interested, language) in one request, about 0.5 s at the median; it was tested in live scripted calls through a relay, and it labels real call turns that score and improve the keyword tool between runs. In the live call the instant keyword tool decides, because the network round trip adds about 0.5 s to a spoken reply; Jev labels real calls between calls. Handler: with a handler name VANI says the name and books with that person; with a pool it says 'our IndiaMART team handles your account; the executive will introduce themselves when they call' and never a made-up name. 'Nahi chahiye' keeps the call open and restates the hook.</a:t>
             </a:r>
           </a:p>
         </p:txBody>
@@ -1523,7 +1523,7 @@
           <a:lstStyle/>
           <a:p>
             <a:r>
-              <a:t>Two layers decide the seller's mood. Layer 1, the keyword tool, runs inside the Sarvam call on every seller turn in well under a millisecond, so the directive applies on the same turn; its measured accuracy is about 0.60 on a small reviewed set, presented as a measurement. Layer 2, Jev (typesafe jev-1.13, a decision model reached through OpenRouter), answers six yes/no mood questions in one request (rushed, frustrated, confused, bot question, interested, language) with a probability for each; about 0.5 s at the median, a tiny fraction of a cent per turn; 49 of 51 correct on a native-script test set and 10 of 10 on a tricky set; it catches cases the keywords miss, such as an irritated 'I am asking again, tell me the price or I hang up'. Jev labels real call turns, which scores and improves the keyword tool between runs (the gold set), and we tested it in live scripted calls through a relay. In the live call the instant keyword tool decides, because a web call to Jev adds about 0.5 s to a spoken reply; Jev runs on real calls after the call and was tested live through a relay. A hybrid that asks Jev only on unclear turns within a strict time budget is the next step. We also evaluated a Sarvam chat model, a small trained classifier and fast hosted models, and measured their latency before choosing this design.</a:t>
+              <a:t>Two layers decide the seller's mood. Layer 1, the keyword tool, runs inside the Sarvam call on every seller turn in well under a millisecond, so the directive applies on the same turn; its measured accuracy is about 0.60 on a small reviewed set, presented as a measurement. Layer 2, Jev (typesafe jev-1.13, a decision model reached through OpenRouter), answers six yes/no mood questions in one request (rushed, frustrated, confused, bot question, interested, language) with a probability for each; about 0.5 s at the median, a tiny fraction of a cent per turn; 49 of 51 correct on a native-script test set and 10 of 10 on a tricky set; it catches cases the keywords miss, such as an irritated 'I am asking again, tell me the price or I hang up'. Jev labels real call turns, which scores and improves the keyword tool between runs (the gold set), and we tested it in live scripted calls through a relay. In the live call the instant keyword tool decides, because a web call to Jev adds about 0.5 s to a spoken reply; Jev labels real calls between calls and was tested live through a relay. A hybrid that asks Jev only on unclear turns within a strict time budget is the next step. We also evaluated a Sarvam chat model, a small trained classifier and fast hosted models, and measured their latency before choosing this design.</a:t>
             </a:r>
           </a:p>
         </p:txBody>
@@ -1697,7 +1697,7 @@
           <a:lstStyle/>
           <a:p>
             <a:r>
-              <a:t>Context builder: offline PS07 and Global Context files, internal APIs (data warehouse, user service, company page) and read-only queries on the buy-lead and catalogue databases write one folder per seller (laptop, VPN). Safe export: names become tokens, a hard PII check refuses any leak, sources are stripped; real names stay on the laptop. Persona agent: Claude Opus 5.5 in an isolated Daytona sandbox; scripts compute traits, states, guards and hook eligibility and propose the top two personas; the agent selects one and decides every field with a checkable reason; a single writer tool, read log, stop gate and validator refuse anything uncited. Compile: the validated persona becomes the Sarvam agent's per-call variables and prompt sections; names are filled in only then, on the laptop. Voice call: the Sarvam voice agent (speech to text, language model, text to speech) with a start tool, a signal tool and a booking tool, one fixed prompt template with per-call variables, and the IndiaMART knowledge base. Review and learning: Claude reviews each call; scoreboards update by seller segment. Compliance: identity rule (never AI, bot or manager; never claims to be human; if pressed, 'IndiaMART's virtual assistant'), verified facts only, no selling on the call, 7 fatal and 13 non-fatal rubric items checked before and after each call; humans approve persona library changes.</a:t>
+              <a:t>Context builder: offline PS07 and Global Context files, internal APIs (data warehouse, user service, company page) and read-only queries on the buy-lead and catalogue databases write one folder per seller (inside IndiaMART, on VPN). Safe export: names become tokens, a hard PII check refuses any leak, sources are stripped; real names stay inside IndiaMART. Persona agent: Claude Opus 5.5 in an isolated Daytona sandbox; scripts compute traits, states, guards and hook eligibility and propose the top two personas; the agent selects one and decides every field with a checkable reason; a single writer tool, read log, stop gate and validator refuse anything uncited. Compile: the validated persona becomes the Sarvam agent's per-call variables and prompt sections; names are filled in only then, at call time. Voice call: the Sarvam voice agent (speech to text, language model, text to speech) with a start tool, a signal tool and a booking tool, one fixed prompt template with per-call variables, and the IndiaMART knowledge base. Review and learning: Claude reviews each call; scoreboards update by seller segment. Compliance: identity rule (never AI, bot or manager; never claims to be human; if pressed, 'IndiaMART's virtual assistant'), verified facts only, no selling on the call, 7 fatal and 13 non-fatal rubric items checked before and after each call; humans approve persona library changes.</a:t>
             </a:r>
           </a:p>
         </p:txBody>
@@ -21851,7 +21851,7 @@
                 </a:solidFill>
                 <a:latin typeface="Arial"/>
               </a:rPr>
-              <a:t>Jev decision model: after the call</a:t>
+              <a:t>Jev decision model: between calls</a:t>
             </a:r>
           </a:p>
           <a:p>
@@ -22135,7 +22135,7 @@
                 </a:solidFill>
                 <a:latin typeface="Arial"/>
               </a:rPr>
-              <a:t>after the call</a:t>
+              <a:t>between calls</a:t>
             </a:r>
           </a:p>
           <a:p>
@@ -22212,7 +22212,7 @@
                 </a:solidFill>
                 <a:latin typeface="Arial"/>
               </a:rPr>
-              <a:t>Keyword tool answers in the call; Jev judges the same turns after the call and teaches it</a:t>
+              <a:t>Keyword tool answers in the call; Jev judges the same turns between calls and teaches it</a:t>
             </a:r>
           </a:p>
         </p:txBody>

</xml_diff>